<commit_message>
Rewrite resource status sheet for a nonprofit operator
Reframes all 12 items assuming the business is run by a nonprofit
organization coordinating universities, IT companies and government.

Co-Authored-By: Claude Opus 5.5 <noreply@anthropic.com>
Claude-Session: https://claude.ai/code/session_01PoDq8kwto3rt92MZRu1n6T
</commit_message>
<xml_diff>
--- a/regional-reskilling/resource-status_regional-reskilling.pptx
+++ b/regional-reskilling/resource-status_regional-reskilling.pptx
@@ -6370,7 +6370,7 @@
                             <a:schemeClr val="tx1"/>
                           </a:solidFill>
                         </a:rPr>
-                        <a:t>情報系の大学教員・研究者が講師陣の中核</a:t>
+                        <a:t>常勤スタッフは少数で、理事・プロボノ・ボランティアが中心</a:t>
                       </a:r>
                     </a:p>
                     <a:p>
@@ -6387,24 +6387,7 @@
                             <a:schemeClr val="tx1"/>
                           </a:solidFill>
                         </a:rPr>
-                        <a:t>社会人向けの実務講師・コーディネーターが不足</a:t>
-                      </a:r>
-                    </a:p>
-                    <a:p>
-                      <a:pPr marL="144000" indent="-144000">
-                        <a:spcBef>
-                          <a:spcPts val="300"/>
-                        </a:spcBef>
-                        <a:buFont typeface="Arial"/>
-                        <a:buChar char="•"/>
-                      </a:pPr>
-                      <a:r>
-                        <a:rPr kumimoji="1" lang="ja-JP" altLang="en-US" sz="1000" b="0" dirty="0">
-                          <a:solidFill>
-                            <a:schemeClr val="tx1"/>
-                          </a:solidFill>
-                        </a:rPr>
-                        <a:t>事務局は少人数で、兼務が中心</a:t>
+                        <a:t>講師は大学教員・IT企業技術者に謝金で依頼</a:t>
                       </a:r>
                     </a:p>
                     <a:p>
@@ -6429,7 +6412,7 @@
                             <a:srgbClr val="007680"/>
                           </a:solidFill>
                         </a:rPr>
-                        <a:t>講座拡大に耐える運営体制が未整備</a:t>
+                        <a:t>常勤のコーディネーター・事務局人材の確保</a:t>
                       </a:r>
                     </a:p>
                   </a:txBody>
@@ -6503,7 +6486,7 @@
                             <a:schemeClr val="tx1"/>
                           </a:solidFill>
                         </a:rPr>
-                        <a:t>講義室・PC演習室・GPUサーバ・配信設備を保有</a:t>
+                        <a:t>自前の拠点は小規模な事務所のみ</a:t>
                       </a:r>
                     </a:p>
                     <a:p>
@@ -6520,7 +6503,7 @@
                             <a:schemeClr val="tx1"/>
                           </a:solidFill>
                         </a:rPr>
-                        <a:t>平日日中は学部授業で稼働率が高い</a:t>
+                        <a:t>会場は連携大学の演習室（夜間・土日）や公共施設・会員企業を借用</a:t>
                       </a:r>
                     </a:p>
                     <a:p>
@@ -6537,7 +6520,7 @@
                             <a:schemeClr val="tx1"/>
                           </a:solidFill>
                         </a:rPr>
-                        <a:t>夜間・土日・長期休暇は遊休で、社会人講座へ転用可能</a:t>
+                        <a:t>オンライン配信機材は最小限を保有</a:t>
                       </a:r>
                     </a:p>
                     <a:p>
@@ -6562,7 +6545,7 @@
                             <a:srgbClr val="007680"/>
                           </a:solidFill>
                         </a:rPr>
-                        <a:t>学外者の利用ルール・予約管理が未整備</a:t>
+                        <a:t>会場確保が貸し手の都合に左右される</a:t>
                       </a:r>
                     </a:p>
                   </a:txBody>
@@ -6636,7 +6619,7 @@
                             <a:schemeClr val="tx1"/>
                           </a:solidFill>
                         </a:rPr>
-                        <a:t>立上げ期は国・自治体の補助金に大きく依存</a:t>
+                        <a:t>収入は補助金・助成金・委託事業が中心</a:t>
                       </a:r>
                     </a:p>
                     <a:p>
@@ -6653,7 +6636,24 @@
                             <a:schemeClr val="tx1"/>
                           </a:solidFill>
                         </a:rPr>
-                        <a:t>受講料などの自主財源はわずか</a:t>
+                        <a:t>会費・寄付・受講料の比率は小さい</a:t>
+                      </a:r>
+                    </a:p>
+                    <a:p>
+                      <a:pPr marL="144000" indent="-144000">
+                        <a:spcBef>
+                          <a:spcPts val="300"/>
+                        </a:spcBef>
+                        <a:buFont typeface="Arial"/>
+                        <a:buChar char="•"/>
+                      </a:pPr>
+                      <a:r>
+                        <a:rPr kumimoji="1" lang="ja-JP" altLang="en-US" sz="1000" b="0" dirty="0">
+                          <a:solidFill>
+                            <a:schemeClr val="tx1"/>
+                          </a:solidFill>
+                        </a:rPr>
+                        <a:t>単年度で終わる事業が多い</a:t>
                       </a:r>
                     </a:p>
                     <a:p>
@@ -6678,7 +6678,7 @@
                             <a:srgbClr val="007680"/>
                           </a:solidFill>
                         </a:rPr>
-                        <a:t>補助金終了後の事業継続性が不透明</a:t>
+                        <a:t>特定の財源に頼らない収入構成づくり</a:t>
                       </a:r>
                     </a:p>
                   </a:txBody>
@@ -6752,7 +6752,7 @@
                             <a:schemeClr val="tx1"/>
                           </a:solidFill>
                         </a:rPr>
-                        <a:t>受講者・修了者データは講座ごとに分散管理</a:t>
+                        <a:t>受講者・会員の情報は表計算ソフトで分散管理</a:t>
                       </a:r>
                     </a:p>
                     <a:p>
@@ -6769,7 +6769,7 @@
                             <a:schemeClr val="tx1"/>
                           </a:solidFill>
                         </a:rPr>
-                        <a:t>LMSは導入済みだが学習ログの活用は限定的</a:t>
+                        <a:t>事業報告用の集計が中心で、分析には未活用</a:t>
                       </a:r>
                     </a:p>
                     <a:p>
@@ -6875,7 +6875,7 @@
                             <a:schemeClr val="tx1"/>
                           </a:solidFill>
                         </a:rPr>
-                        <a:t>教員：AI・データサイエンスの学術専門性が高い</a:t>
+                        <a:t>理事・会員にIT企業経営者・大学教員・元行政職員</a:t>
                       </a:r>
                     </a:p>
                     <a:p>
@@ -6892,7 +6892,7 @@
                             <a:schemeClr val="tx1"/>
                           </a:solidFill>
                         </a:rPr>
-                        <a:t>IT企業技術者：実装・現場経験が豊富（10年超も）</a:t>
+                        <a:t>プロボノ技術者は実装・現場経験が豊富</a:t>
                       </a:r>
                     </a:p>
                     <a:p>
@@ -6909,7 +6909,7 @@
                             <a:schemeClr val="tx1"/>
                           </a:solidFill>
                         </a:rPr>
-                        <a:t>行政職員：DX推進の現場知を保有</a:t>
+                        <a:t>スタッフは運営・地域調整に強い</a:t>
                       </a:r>
                     </a:p>
                     <a:p>
@@ -6934,7 +6934,7 @@
                             <a:srgbClr val="007680"/>
                           </a:solidFill>
                         </a:rPr>
-                        <a:t>経営層に「教える」経験・ノウハウが浅い</a:t>
+                        <a:t>経営層向け研修の企画力</a:t>
                       </a:r>
                     </a:p>
                   </a:txBody>
@@ -7008,7 +7008,7 @@
                             <a:schemeClr val="tx1"/>
                           </a:solidFill>
                         </a:rPr>
-                        <a:t>産学官連携によるDX/AX実践型リスキリング講座</a:t>
+                        <a:t>非営利・中立の立場で産学官をつなぐDX/AX講座</a:t>
                       </a:r>
                     </a:p>
                     <a:p>
@@ -7042,7 +7042,7 @@
                             <a:schemeClr val="tx1"/>
                           </a:solidFill>
                         </a:rPr>
-                        <a:t>学生と社会人が共に学ぶ場、履修証明を発行</a:t>
+                        <a:t>学生と社会人が共に学ぶ場をつくる</a:t>
                       </a:r>
                     </a:p>
                     <a:p>
@@ -7141,7 +7141,7 @@
                             <a:schemeClr val="tx1"/>
                           </a:solidFill>
                         </a:rPr>
-                        <a:t>主なコストは講師謝金・教材開発・事務局人件費</a:t>
+                        <a:t>主なコストは講師謝金・人件費・会場費</a:t>
                       </a:r>
                     </a:p>
                     <a:p>
@@ -7158,7 +7158,7 @@
                             <a:schemeClr val="tx1"/>
                           </a:solidFill>
                         </a:rPr>
-                        <a:t>大学施設の活用で設備コストは低い</a:t>
+                        <a:t>プロボノと借用施設で固定費は低い</a:t>
                       </a:r>
                     </a:p>
                     <a:p>
@@ -7200,7 +7200,7 @@
                             <a:srgbClr val="007680"/>
                           </a:solidFill>
                         </a:rPr>
-                        <a:t>企業負担型メニューの確立</a:t>
+                        <a:t>企業負担型の有料メニューの確立</a:t>
                       </a:r>
                     </a:p>
                   </a:txBody>
@@ -7274,7 +7274,7 @@
                             <a:schemeClr val="tx1"/>
                           </a:solidFill>
                         </a:rPr>
-                        <a:t>地元IT企業（業界団体経由）、自治体職員、在学生</a:t>
+                        <a:t>会員のIT企業、自治体職員、連携大学の学生</a:t>
                       </a:r>
                     </a:p>
                     <a:p>
@@ -7397,7 +7397,7 @@
                             <a:schemeClr val="tx1"/>
                           </a:solidFill>
                         </a:rPr>
-                        <a:t>大学・IT企業・行政の連携は個人の人脈頼み</a:t>
+                        <a:t>大学・IT企業・行政をつなぐ中立的なハブ役</a:t>
                       </a:r>
                     </a:p>
                     <a:p>
@@ -7414,7 +7414,7 @@
                             <a:schemeClr val="tx1"/>
                           </a:solidFill>
                         </a:rPr>
-                        <a:t>学内でも学部・センター間の協働は限定的</a:t>
+                        <a:t>ただし連携は理事個人の人脈頼み</a:t>
                       </a:r>
                     </a:p>
                     <a:p>
@@ -7439,7 +7439,7 @@
                             <a:srgbClr val="007680"/>
                           </a:solidFill>
                         </a:rPr>
-                        <a:t>産学官の常設協議体と役割分担が未整備</a:t>
+                        <a:t>連携協定など組織的な枠組みが未整備</a:t>
                       </a:r>
                     </a:p>
                   </a:txBody>
@@ -7513,7 +7513,7 @@
                             <a:schemeClr val="tx1"/>
                           </a:solidFill>
                         </a:rPr>
-                        <a:t>大学のAI・データ分析研究</a:t>
+                        <a:t>講師陣と共同開発した講座・教材</a:t>
                       </a:r>
                     </a:p>
                     <a:p>
@@ -7547,7 +7547,7 @@
                             <a:schemeClr val="tx1"/>
                           </a:solidFill>
                         </a:rPr>
-                        <a:t>オンデマンド教材・演習環境の蓄積</a:t>
+                        <a:t>連携大学の研究成果を活用できる</a:t>
                       </a:r>
                     </a:p>
                     <a:p>
@@ -7572,7 +7572,7 @@
                             <a:srgbClr val="007680"/>
                           </a:solidFill>
                         </a:rPr>
-                        <a:t>教材の体系化と知財としての権利整理が未着手</a:t>
+                        <a:t>教材の著作権の帰属（講師・大学）が未整理</a:t>
                       </a:r>
                     </a:p>
                   </a:txBody>
@@ -7646,7 +7646,7 @@
                             <a:schemeClr val="tx1"/>
                           </a:solidFill>
                         </a:rPr>
-                        <a:t>補助金・企業版ふるさと納税の活用余地あり</a:t>
+                        <a:t>民間財団の助成、休眠預金活用事業に応募可能</a:t>
                       </a:r>
                     </a:p>
                     <a:p>
@@ -7663,7 +7663,7 @@
                             <a:schemeClr val="tx1"/>
                           </a:solidFill>
                         </a:rPr>
-                        <a:t>地域金融機関との連携（協賛・融資）の余地あり</a:t>
+                        <a:t>自治体の委託事業を受託できる</a:t>
                       </a:r>
                     </a:p>
                     <a:p>
@@ -7680,7 +7680,7 @@
                             <a:schemeClr val="tx1"/>
                           </a:solidFill>
                         </a:rPr>
-                        <a:t>受講企業は国の人材開発支援助成金を活用可能</a:t>
+                        <a:t>寄付を募れる（認定NPOは税優遇）</a:t>
                       </a:r>
                     </a:p>
                     <a:p>
@@ -7705,7 +7705,7 @@
                             <a:srgbClr val="007680"/>
                           </a:solidFill>
                         </a:rPr>
-                        <a:t>自前の新規投資余力は限定的</a:t>
+                        <a:t>融資を受けにくく、先行投資の余力が乏しい</a:t>
                       </a:r>
                     </a:p>
                   </a:txBody>
@@ -7796,7 +7796,7 @@
                             <a:schemeClr val="tx1"/>
                           </a:solidFill>
                         </a:rPr>
-                        <a:t>民間オンライン講座・他大学など競合の把握が不十分</a:t>
+                        <a:t>民間オンライン講座・大学など競合の把握が不十分</a:t>
                       </a:r>
                     </a:p>
                     <a:p>
@@ -7917,7 +7917,7 @@
                   <a:schemeClr val="tx1"/>
                 </a:solidFill>
               </a:rPr>
-              <a:t>（AI・情報人材の育成／産学官連携・記入例）</a:t>
+              <a:t>（運営：非営利組織／AI・情報人材の育成・記入例）</a:t>
             </a:r>
           </a:p>
         </p:txBody>

</xml_diff>